<commit_message>
adds skeleton for docs and errors
</commit_message>
<xml_diff>
--- a/Intro to Computers/Lesson 04 - Reading/Reading.pptx
+++ b/Intro to Computers/Lesson 04 - Reading/Reading.pptx
@@ -5,7 +5,7 @@
     <p:sldMasterId id="2147483695" r:id="rId1"/>
   </p:sldMasterIdLst>
   <p:notesMasterIdLst>
-    <p:notesMasterId r:id="rId20"/>
+    <p:notesMasterId r:id="rId26"/>
   </p:notesMasterIdLst>
   <p:sldIdLst>
     <p:sldId id="271" r:id="rId2"/>
@@ -25,7 +25,13 @@
     <p:sldId id="287" r:id="rId16"/>
     <p:sldId id="288" r:id="rId17"/>
     <p:sldId id="289" r:id="rId18"/>
-    <p:sldId id="290" r:id="rId19"/>
+    <p:sldId id="291" r:id="rId19"/>
+    <p:sldId id="292" r:id="rId20"/>
+    <p:sldId id="295" r:id="rId21"/>
+    <p:sldId id="293" r:id="rId22"/>
+    <p:sldId id="296" r:id="rId23"/>
+    <p:sldId id="294" r:id="rId24"/>
+    <p:sldId id="290" r:id="rId25"/>
   </p:sldIdLst>
   <p:sldSz cx="12192000" cy="6858000"/>
   <p:notesSz cx="6858000" cy="9144000"/>
@@ -214,7 +220,7 @@
           <a:p>
             <a:fld id="{7D2F5B96-EC90-4B10-91AC-E32DA21E81E1}" type="datetimeFigureOut">
               <a:rPr lang="en-US" smtClean="0"/>
-              <a:t>7/8/2026</a:t>
+              <a:t>7/9/2026</a:t>
             </a:fld>
             <a:endParaRPr lang="en-US"/>
           </a:p>
@@ -616,7 +622,7 @@
           <a:p>
             <a:fld id="{7A3E0868-4E26-4CDC-8A56-D70E2D8B12FE}" type="datetime3">
               <a:rPr lang="en-US" smtClean="0"/>
-              <a:t>8 July 2026</a:t>
+              <a:t>9 July 2026</a:t>
             </a:fld>
             <a:endParaRPr lang="en-US"/>
           </a:p>
@@ -3193,7 +3199,7 @@
           <a:p>
             <a:fld id="{A7B8021B-6105-4216-96FC-94348F216D0E}" type="datetime3">
               <a:rPr lang="en-US" smtClean="0"/>
-              <a:t>8 July 2026</a:t>
+              <a:t>9 July 2026</a:t>
             </a:fld>
             <a:endParaRPr lang="en-US"/>
           </a:p>
@@ -4891,7 +4897,7 @@
           <a:p>
             <a:fld id="{5D27CFAB-73E6-44A8-B862-B3306344E3F2}" type="datetime3">
               <a:rPr lang="en-US" smtClean="0"/>
-              <a:t>8 July 2026</a:t>
+              <a:t>9 July 2026</a:t>
             </a:fld>
             <a:endParaRPr lang="en-US"/>
           </a:p>
@@ -6682,7 +6688,7 @@
           <a:p>
             <a:fld id="{A9B2E784-A5F5-4301-881B-94AC8DBF9DED}" type="datetime3">
               <a:rPr lang="en-US" smtClean="0"/>
-              <a:t>8 July 2026</a:t>
+              <a:t>9 July 2026</a:t>
             </a:fld>
             <a:endParaRPr lang="en-US"/>
           </a:p>
@@ -6862,7 +6868,7 @@
           <a:p>
             <a:fld id="{18EAB3A5-9E92-4BB9-8F22-9632B4FBEDBA}" type="datetime3">
               <a:rPr lang="en-US" smtClean="0"/>
-              <a:t>8 July 2026</a:t>
+              <a:t>9 July 2026</a:t>
             </a:fld>
             <a:endParaRPr lang="en-US"/>
           </a:p>
@@ -7090,7 +7096,7 @@
           <a:p>
             <a:fld id="{40923810-5FB2-48C9-96CA-1DE2C4773142}" type="datetime3">
               <a:rPr lang="en-US" smtClean="0"/>
-              <a:t>8 July 2026</a:t>
+              <a:t>9 July 2026</a:t>
             </a:fld>
             <a:endParaRPr lang="en-US"/>
           </a:p>
@@ -7381,7 +7387,7 @@
           <a:p>
             <a:fld id="{E50EFF4B-86EB-42FB-93EA-7D8F9CB2466F}" type="datetime3">
               <a:rPr lang="en-US" smtClean="0"/>
-              <a:t>8 July 2026</a:t>
+              <a:t>9 July 2026</a:t>
             </a:fld>
             <a:endParaRPr lang="en-US"/>
           </a:p>
@@ -7994,7 +8000,7 @@
           <a:p>
             <a:fld id="{FB14FC24-E041-45E9-9A72-E5755A86890F}" type="datetime3">
               <a:rPr lang="en-US" smtClean="0"/>
-              <a:t>8 July 2026</a:t>
+              <a:t>9 July 2026</a:t>
             </a:fld>
             <a:endParaRPr lang="en-US"/>
           </a:p>
@@ -8855,7 +8861,7 @@
           <a:p>
             <a:fld id="{98A19125-94A7-4474-858C-FD9C4ABE9DDA}" type="datetime3">
               <a:rPr lang="en-US" smtClean="0"/>
-              <a:t>8 July 2026</a:t>
+              <a:t>9 July 2026</a:t>
             </a:fld>
             <a:endParaRPr lang="en-US"/>
           </a:p>
@@ -9959,7 +9965,7 @@
           <a:p>
             <a:fld id="{3BA0343D-C8D8-43CE-BB79-50DEA219DB07}" type="datetime3">
               <a:rPr lang="en-US" smtClean="0"/>
-              <a:t>8 July 2026</a:t>
+              <a:t>9 July 2026</a:t>
             </a:fld>
             <a:endParaRPr lang="en-US"/>
           </a:p>
@@ -10249,7 +10255,7 @@
           <a:p>
             <a:fld id="{453BD212-0B9F-4987-965F-AC83B2FC354F}" type="datetime3">
               <a:rPr lang="en-US" smtClean="0"/>
-              <a:t>8 July 2026</a:t>
+              <a:t>9 July 2026</a:t>
             </a:fld>
             <a:endParaRPr lang="en-US"/>
           </a:p>
@@ -10493,7 +10499,7 @@
           <a:p>
             <a:fld id="{6DDC931E-8CBE-4A3F-A034-9B6122C6DCDB}" type="datetime3">
               <a:rPr lang="en-US" smtClean="0"/>
-              <a:t>8 July 2026</a:t>
+              <a:t>9 July 2026</a:t>
             </a:fld>
             <a:endParaRPr lang="en-US"/>
           </a:p>
@@ -12276,7 +12282,7 @@
           <a:p>
             <a:fld id="{220AF9C2-5E8A-4308-AE6B-CA9B65007D0E}" type="datetime3">
               <a:rPr lang="en-US" smtClean="0"/>
-              <a:t>8 July 2026</a:t>
+              <a:t>9 July 2026</a:t>
             </a:fld>
             <a:endParaRPr lang="en-US"/>
           </a:p>
@@ -12590,7 +12596,7 @@
           <a:p>
             <a:fld id="{FF31E861-D2AF-431D-860B-DCF67C218052}" type="datetime3">
               <a:rPr lang="en-US" smtClean="0"/>
-              <a:t>8 July 2026</a:t>
+              <a:t>9 July 2026</a:t>
             </a:fld>
             <a:endParaRPr lang="en-US"/>
           </a:p>
@@ -12870,7 +12876,7 @@
           <a:p>
             <a:fld id="{D1DA25B2-AAF1-4C1F-AA38-12D5BFA7D4C8}" type="datetime3">
               <a:rPr lang="en-US" smtClean="0"/>
-              <a:t>8 July 2026</a:t>
+              <a:t>9 July 2026</a:t>
             </a:fld>
             <a:endParaRPr lang="en-US"/>
           </a:p>
@@ -13150,7 +13156,7 @@
           <a:p>
             <a:fld id="{A25C0F39-45D0-48E9-90B3-7FE8FCE561C8}" type="datetime3">
               <a:rPr lang="en-US" smtClean="0"/>
-              <a:t>8 July 2026</a:t>
+              <a:t>9 July 2026</a:t>
             </a:fld>
             <a:endParaRPr lang="en-US"/>
           </a:p>
@@ -13652,7 +13658,7 @@
           <a:p>
             <a:fld id="{9BAF1A3D-92FA-4F24-9781-74AFA516A230}" type="datetime3">
               <a:rPr lang="en-US" smtClean="0"/>
-              <a:t>8 July 2026</a:t>
+              <a:t>9 July 2026</a:t>
             </a:fld>
             <a:endParaRPr lang="en-US"/>
           </a:p>
@@ -13780,7 +13786,7 @@
           <a:p>
             <a:fld id="{5719C672-856D-4617-A693-8FE15749A9B7}" type="datetime3">
               <a:rPr lang="en-US" smtClean="0"/>
-              <a:t>8 July 2026</a:t>
+              <a:t>9 July 2026</a:t>
             </a:fld>
             <a:endParaRPr lang="en-US"/>
           </a:p>
@@ -13916,7 +13922,7 @@
           <a:p>
             <a:fld id="{5F6C764D-A39E-4C03-B161-E0BC66E8883B}" type="datetime3">
               <a:rPr lang="en-US" smtClean="0"/>
-              <a:t>8 July 2026</a:t>
+              <a:t>9 July 2026</a:t>
             </a:fld>
             <a:endParaRPr lang="en-US"/>
           </a:p>
@@ -14155,7 +14161,7 @@
           <a:p>
             <a:fld id="{6E3E33F9-20B7-4995-BE7D-165DBB597850}" type="datetime3">
               <a:rPr lang="en-US" smtClean="0"/>
-              <a:t>8 July 2026</a:t>
+              <a:t>9 July 2026</a:t>
             </a:fld>
             <a:endParaRPr lang="en-US"/>
           </a:p>
@@ -14269,7 +14275,7 @@
           <a:p>
             <a:fld id="{CD41C263-3501-4369-A962-62B6BF915CDE}" type="datetime3">
               <a:rPr lang="en-US" smtClean="0"/>
-              <a:t>8 July 2026</a:t>
+              <a:t>9 July 2026</a:t>
             </a:fld>
             <a:endParaRPr lang="en-US"/>
           </a:p>
@@ -14673,7 +14679,7 @@
           <a:p>
             <a:fld id="{B06F3EBE-B2E8-4992-9F00-9E4B44F057C0}" type="datetime3">
               <a:rPr lang="en-US" smtClean="0"/>
-              <a:t>8 July 2026</a:t>
+              <a:t>9 July 2026</a:t>
             </a:fld>
             <a:endParaRPr lang="en-US"/>
           </a:p>
@@ -14806,7 +14812,7 @@
           <a:p>
             <a:fld id="{D41656AB-D2E1-472E-8B95-0DF5C6E1D623}" type="datetime3">
               <a:rPr lang="en-US" smtClean="0"/>
-              <a:t>8 July 2026</a:t>
+              <a:t>9 July 2026</a:t>
             </a:fld>
             <a:endParaRPr lang="en-US"/>
           </a:p>
@@ -16793,7 +16799,7 @@
           <a:p>
             <a:fld id="{AD3160A9-B1E4-4AE8-B854-46ED2C2068C2}" type="datetimeFigureOut">
               <a:rPr lang="en-US" smtClean="0"/>
-              <a:t>7/8/2026</a:t>
+              <a:t>7/9/2026</a:t>
             </a:fld>
             <a:endParaRPr lang="en-US"/>
           </a:p>
@@ -16989,7 +16995,7 @@
           <a:p>
             <a:fld id="{AD622D1A-DF83-41A8-85FF-04D90BF831D3}" type="datetime3">
               <a:rPr lang="en-US" smtClean="0"/>
-              <a:t>8 July 2026</a:t>
+              <a:t>9 July 2026</a:t>
             </a:fld>
             <a:endParaRPr lang="en-US"/>
           </a:p>
@@ -17240,7 +17246,7 @@
           <a:p>
             <a:fld id="{334F72C3-CDF3-44A8-B602-1649B1728485}" type="datetime3">
               <a:rPr lang="en-US" smtClean="0"/>
-              <a:t>8 July 2026</a:t>
+              <a:t>9 July 2026</a:t>
             </a:fld>
             <a:endParaRPr lang="en-US"/>
           </a:p>
@@ -17548,7 +17554,7 @@
           <a:p>
             <a:fld id="{1E0132BA-B5E7-4FFD-AF6C-169169D47D4A}" type="datetime3">
               <a:rPr lang="en-US" smtClean="0"/>
-              <a:t>8 July 2026</a:t>
+              <a:t>9 July 2026</a:t>
             </a:fld>
             <a:endParaRPr lang="en-US"/>
           </a:p>
@@ -18030,7 +18036,7 @@
           <a:p>
             <a:fld id="{81A30091-1C2A-4151-8D3C-D1E47A72615F}" type="datetime3">
               <a:rPr lang="en-US" smtClean="0"/>
-              <a:t>8 July 2026</a:t>
+              <a:t>9 July 2026</a:t>
             </a:fld>
             <a:endParaRPr lang="en-US"/>
           </a:p>
@@ -18668,7 +18674,7 @@
           <a:p>
             <a:fld id="{35D703CE-07B4-4C05-A488-B4566700621F}" type="datetime3">
               <a:rPr lang="en-US" smtClean="0"/>
-              <a:t>8 July 2026</a:t>
+              <a:t>9 July 2026</a:t>
             </a:fld>
             <a:endParaRPr lang="en-US"/>
           </a:p>
@@ -19727,7 +19733,7 @@
           <a:p>
             <a:fld id="{694BD61C-20BA-43AF-A21F-1DAFB3200099}" type="datetime3">
               <a:rPr lang="en-US" smtClean="0"/>
-              <a:t>8 July 2026</a:t>
+              <a:t>9 July 2026</a:t>
             </a:fld>
             <a:endParaRPr lang="en-US"/>
           </a:p>
@@ -20216,7 +20222,7 @@
           <a:p>
             <a:fld id="{CABCB1B0-B6E5-4DD1-BB55-95C076D6C0C8}" type="datetime3">
               <a:rPr lang="en-US" smtClean="0"/>
-              <a:t>8 July 2026</a:t>
+              <a:t>9 July 2026</a:t>
             </a:fld>
             <a:endParaRPr lang="en-US"/>
           </a:p>
@@ -20760,7 +20766,7 @@
           <a:p>
             <a:fld id="{7A3E0868-4E26-4CDC-8A56-D70E2D8B12FE}" type="datetime3">
               <a:rPr lang="en-US" smtClean="0"/>
-              <a:t>8 July 2026</a:t>
+              <a:t>9 July 2026</a:t>
             </a:fld>
             <a:endParaRPr lang="en-US" dirty="0"/>
           </a:p>
@@ -23157,7 +23163,7 @@
           <a:bodyPr/>
           <a:lstStyle/>
           <a:p>
-            <a:endParaRPr lang="en-US"/>
+            <a:endParaRPr lang="en-US" dirty="0"/>
           </a:p>
         </p:txBody>
       </p:sp>
@@ -23196,7 +23202,7 @@
           <p:cNvPr id="2" name="Title 1">
             <a:extLst>
               <a:ext uri="{FF2B5EF4-FFF2-40B4-BE49-F238E27FC236}">
-                <a16:creationId xmlns:a16="http://schemas.microsoft.com/office/drawing/2014/main" id="{8D3BCC3E-3DC9-E773-3FF1-CDF396B7E726}"/>
+                <a16:creationId xmlns:a16="http://schemas.microsoft.com/office/drawing/2014/main" id="{C78B07FD-2C85-D8E1-B4A7-5C2B83EC784A}"/>
               </a:ext>
             </a:extLst>
           </p:cNvPr>
@@ -23213,10 +23219,9 @@
           <a:lstStyle/>
           <a:p>
             <a:r>
-              <a:rPr lang="en-US"/>
+              <a:rPr lang="en-US" dirty="0"/>
               <a:t>Documentation</a:t>
             </a:r>
-            <a:endParaRPr lang="en-US" dirty="0"/>
           </a:p>
         </p:txBody>
       </p:sp>
@@ -23225,7 +23230,7 @@
           <p:cNvPr id="3" name="Content Placeholder 2">
             <a:extLst>
               <a:ext uri="{FF2B5EF4-FFF2-40B4-BE49-F238E27FC236}">
-                <a16:creationId xmlns:a16="http://schemas.microsoft.com/office/drawing/2014/main" id="{2B964104-7D38-7412-6BCE-1796D82C1FA5}"/>
+                <a16:creationId xmlns:a16="http://schemas.microsoft.com/office/drawing/2014/main" id="{DFD1B84A-AC40-8C57-ED9B-49DF54A1FCAC}"/>
               </a:ext>
             </a:extLst>
           </p:cNvPr>
@@ -23241,14 +23246,138 @@
           <a:bodyPr/>
           <a:lstStyle/>
           <a:p>
-            <a:endParaRPr lang="en-US"/>
+            <a:r>
+              <a:rPr lang="en-US" dirty="0"/>
+              <a:t>Read with a purpose</a:t>
+            </a:r>
+          </a:p>
+          <a:p>
+            <a:r>
+              <a:rPr lang="en-US" dirty="0"/>
+              <a:t>Be like Goldilocks when you’re skimming</a:t>
+            </a:r>
+          </a:p>
+          <a:p>
+            <a:r>
+              <a:rPr lang="en-US" dirty="0"/>
+              <a:t>Slow </a:t>
+            </a:r>
+            <a:r>
+              <a:rPr lang="en-US"/>
+              <a:t>is smooth…</a:t>
+            </a:r>
+            <a:endParaRPr lang="en-US" dirty="0"/>
           </a:p>
         </p:txBody>
       </p:sp>
     </p:spTree>
     <p:extLst>
       <p:ext uri="{BB962C8B-B14F-4D97-AF65-F5344CB8AC3E}">
-        <p14:creationId xmlns:p14="http://schemas.microsoft.com/office/powerpoint/2010/main" val="3513312863"/>
+        <p14:creationId xmlns:p14="http://schemas.microsoft.com/office/powerpoint/2010/main" val="4006852009"/>
+      </p:ext>
+    </p:extLst>
+  </p:cSld>
+  <p:clrMapOvr>
+    <a:masterClrMapping/>
+  </p:clrMapOvr>
+</p:sld>
+</file>
+
+<file path=ppt/slides/slide19.xml><?xml version="1.0" encoding="utf-8"?>
+<p:sld xmlns:a="http://schemas.openxmlformats.org/drawingml/2006/main" xmlns:r="http://schemas.openxmlformats.org/officeDocument/2006/relationships" xmlns:p="http://schemas.openxmlformats.org/presentationml/2006/main">
+  <p:cSld>
+    <p:spTree>
+      <p:nvGrpSpPr>
+        <p:cNvPr id="1" name=""/>
+        <p:cNvGrpSpPr/>
+        <p:nvPr/>
+      </p:nvGrpSpPr>
+      <p:grpSpPr>
+        <a:xfrm>
+          <a:off x="0" y="0"/>
+          <a:ext cx="0" cy="0"/>
+          <a:chOff x="0" y="0"/>
+          <a:chExt cx="0" cy="0"/>
+        </a:xfrm>
+      </p:grpSpPr>
+      <p:sp>
+        <p:nvSpPr>
+          <p:cNvPr id="2" name="Title 1">
+            <a:extLst>
+              <a:ext uri="{FF2B5EF4-FFF2-40B4-BE49-F238E27FC236}">
+                <a16:creationId xmlns:a16="http://schemas.microsoft.com/office/drawing/2014/main" id="{B62BCFAC-A47D-DB2A-94A1-532EA58EED2F}"/>
+              </a:ext>
+            </a:extLst>
+          </p:cNvPr>
+          <p:cNvSpPr>
+            <a:spLocks noGrp="1"/>
+          </p:cNvSpPr>
+          <p:nvPr>
+            <p:ph type="title"/>
+          </p:nvPr>
+        </p:nvSpPr>
+        <p:spPr/>
+        <p:txBody>
+          <a:bodyPr/>
+          <a:lstStyle/>
+          <a:p>
+            <a:r>
+              <a:rPr lang="en-US" dirty="0"/>
+              <a:t>Command Line</a:t>
+            </a:r>
+          </a:p>
+        </p:txBody>
+      </p:sp>
+      <p:sp>
+        <p:nvSpPr>
+          <p:cNvPr id="3" name="Content Placeholder 2">
+            <a:extLst>
+              <a:ext uri="{FF2B5EF4-FFF2-40B4-BE49-F238E27FC236}">
+                <a16:creationId xmlns:a16="http://schemas.microsoft.com/office/drawing/2014/main" id="{22704368-D538-96CF-7ACF-DD3EE168D7D7}"/>
+              </a:ext>
+            </a:extLst>
+          </p:cNvPr>
+          <p:cNvSpPr>
+            <a:spLocks noGrp="1"/>
+          </p:cNvSpPr>
+          <p:nvPr>
+            <p:ph idx="1"/>
+          </p:nvPr>
+        </p:nvSpPr>
+        <p:spPr/>
+        <p:txBody>
+          <a:bodyPr/>
+          <a:lstStyle/>
+          <a:p>
+            <a:r>
+              <a:rPr lang="en-US" dirty="0">
+                <a:latin typeface="Courier New" panose="02070309020205020404" pitchFamily="49" charset="0"/>
+                <a:cs typeface="Courier New" panose="02070309020205020404" pitchFamily="49" charset="0"/>
+              </a:rPr>
+              <a:t>[command] --help</a:t>
+            </a:r>
+          </a:p>
+          <a:p>
+            <a:r>
+              <a:rPr lang="en-US" dirty="0">
+                <a:latin typeface="Courier New" panose="02070309020205020404" pitchFamily="49" charset="0"/>
+                <a:cs typeface="Courier New" panose="02070309020205020404" pitchFamily="49" charset="0"/>
+              </a:rPr>
+              <a:t>man [command]</a:t>
+            </a:r>
+          </a:p>
+          <a:p>
+            <a:endParaRPr lang="en-US" dirty="0">
+              <a:latin typeface="Courier New" panose="02070309020205020404" pitchFamily="49" charset="0"/>
+              <a:cs typeface="Courier New" panose="02070309020205020404" pitchFamily="49" charset="0"/>
+            </a:endParaRPr>
+          </a:p>
+        </p:txBody>
+      </p:sp>
+    </p:spTree>
+    <p:extLst>
+      <p:ext uri="{BB962C8B-B14F-4D97-AF65-F5344CB8AC3E}">
+        <p14:creationId xmlns:p14="http://schemas.microsoft.com/office/powerpoint/2010/main" val="2537902175"/>
       </p:ext>
     </p:extLst>
   </p:cSld>
@@ -23347,6 +23476,802 @@
     <p:extLst>
       <p:ext uri="{BB962C8B-B14F-4D97-AF65-F5344CB8AC3E}">
         <p14:creationId xmlns:p14="http://schemas.microsoft.com/office/powerpoint/2010/main" val="3646994342"/>
+      </p:ext>
+    </p:extLst>
+  </p:cSld>
+  <p:clrMapOvr>
+    <a:masterClrMapping/>
+  </p:clrMapOvr>
+</p:sld>
+</file>
+
+<file path=ppt/slides/slide20.xml><?xml version="1.0" encoding="utf-8"?>
+<p:sld xmlns:a="http://schemas.openxmlformats.org/drawingml/2006/main" xmlns:r="http://schemas.openxmlformats.org/officeDocument/2006/relationships" xmlns:p="http://schemas.openxmlformats.org/presentationml/2006/main">
+  <p:cSld>
+    <p:spTree>
+      <p:nvGrpSpPr>
+        <p:cNvPr id="1" name=""/>
+        <p:cNvGrpSpPr/>
+        <p:nvPr/>
+      </p:nvGrpSpPr>
+      <p:grpSpPr>
+        <a:xfrm>
+          <a:off x="0" y="0"/>
+          <a:ext cx="0" cy="0"/>
+          <a:chOff x="0" y="0"/>
+          <a:chExt cx="0" cy="0"/>
+        </a:xfrm>
+      </p:grpSpPr>
+      <p:sp>
+        <p:nvSpPr>
+          <p:cNvPr id="2" name="Title 1">
+            <a:extLst>
+              <a:ext uri="{FF2B5EF4-FFF2-40B4-BE49-F238E27FC236}">
+                <a16:creationId xmlns:a16="http://schemas.microsoft.com/office/drawing/2014/main" id="{864D23A5-5003-524D-C8E8-B1D433424DC7}"/>
+              </a:ext>
+            </a:extLst>
+          </p:cNvPr>
+          <p:cNvSpPr>
+            <a:spLocks noGrp="1"/>
+          </p:cNvSpPr>
+          <p:nvPr>
+            <p:ph type="title"/>
+          </p:nvPr>
+        </p:nvSpPr>
+        <p:spPr/>
+        <p:txBody>
+          <a:bodyPr/>
+          <a:lstStyle/>
+          <a:p>
+            <a:r>
+              <a:rPr lang="en-US" dirty="0"/>
+              <a:t>CLI Examples</a:t>
+            </a:r>
+          </a:p>
+        </p:txBody>
+      </p:sp>
+      <p:sp>
+        <p:nvSpPr>
+          <p:cNvPr id="3" name="Content Placeholder 2">
+            <a:extLst>
+              <a:ext uri="{FF2B5EF4-FFF2-40B4-BE49-F238E27FC236}">
+                <a16:creationId xmlns:a16="http://schemas.microsoft.com/office/drawing/2014/main" id="{0FB57D57-D7D6-53A3-10B6-8032522FFA23}"/>
+              </a:ext>
+            </a:extLst>
+          </p:cNvPr>
+          <p:cNvSpPr>
+            <a:spLocks noGrp="1"/>
+          </p:cNvSpPr>
+          <p:nvPr>
+            <p:ph idx="1"/>
+          </p:nvPr>
+        </p:nvSpPr>
+        <p:spPr/>
+        <p:txBody>
+          <a:bodyPr/>
+          <a:lstStyle/>
+          <a:p>
+            <a:endParaRPr lang="en-US"/>
+          </a:p>
+        </p:txBody>
+      </p:sp>
+    </p:spTree>
+    <p:extLst>
+      <p:ext uri="{BB962C8B-B14F-4D97-AF65-F5344CB8AC3E}">
+        <p14:creationId xmlns:p14="http://schemas.microsoft.com/office/powerpoint/2010/main" val="2680889284"/>
+      </p:ext>
+    </p:extLst>
+  </p:cSld>
+  <p:clrMapOvr>
+    <a:masterClrMapping/>
+  </p:clrMapOvr>
+</p:sld>
+</file>
+
+<file path=ppt/slides/slide21.xml><?xml version="1.0" encoding="utf-8"?>
+<p:sld xmlns:a="http://schemas.openxmlformats.org/drawingml/2006/main" xmlns:r="http://schemas.openxmlformats.org/officeDocument/2006/relationships" xmlns:p="http://schemas.openxmlformats.org/presentationml/2006/main">
+  <p:cSld>
+    <p:spTree>
+      <p:nvGrpSpPr>
+        <p:cNvPr id="1" name=""/>
+        <p:cNvGrpSpPr/>
+        <p:nvPr/>
+      </p:nvGrpSpPr>
+      <p:grpSpPr>
+        <a:xfrm>
+          <a:off x="0" y="0"/>
+          <a:ext cx="0" cy="0"/>
+          <a:chOff x="0" y="0"/>
+          <a:chExt cx="0" cy="0"/>
+        </a:xfrm>
+      </p:grpSpPr>
+      <p:sp>
+        <p:nvSpPr>
+          <p:cNvPr id="2" name="Title 1">
+            <a:extLst>
+              <a:ext uri="{FF2B5EF4-FFF2-40B4-BE49-F238E27FC236}">
+                <a16:creationId xmlns:a16="http://schemas.microsoft.com/office/drawing/2014/main" id="{343BBCE9-3627-90CF-ADC5-FB1F40536C04}"/>
+              </a:ext>
+            </a:extLst>
+          </p:cNvPr>
+          <p:cNvSpPr>
+            <a:spLocks noGrp="1"/>
+          </p:cNvSpPr>
+          <p:nvPr>
+            <p:ph type="title"/>
+          </p:nvPr>
+        </p:nvSpPr>
+        <p:spPr/>
+        <p:txBody>
+          <a:bodyPr/>
+          <a:lstStyle/>
+          <a:p>
+            <a:r>
+              <a:rPr lang="en-US" dirty="0"/>
+              <a:t>Online</a:t>
+            </a:r>
+          </a:p>
+        </p:txBody>
+      </p:sp>
+      <p:sp>
+        <p:nvSpPr>
+          <p:cNvPr id="3" name="Content Placeholder 2">
+            <a:extLst>
+              <a:ext uri="{FF2B5EF4-FFF2-40B4-BE49-F238E27FC236}">
+                <a16:creationId xmlns:a16="http://schemas.microsoft.com/office/drawing/2014/main" id="{38400833-0CAC-8541-F8D8-98E57125924F}"/>
+              </a:ext>
+            </a:extLst>
+          </p:cNvPr>
+          <p:cNvSpPr>
+            <a:spLocks noGrp="1"/>
+          </p:cNvSpPr>
+          <p:nvPr>
+            <p:ph idx="1"/>
+          </p:nvPr>
+        </p:nvSpPr>
+        <p:spPr/>
+        <p:txBody>
+          <a:bodyPr/>
+          <a:lstStyle/>
+          <a:p>
+            <a:r>
+              <a:rPr lang="en-US" dirty="0"/>
+              <a:t>Best to refer to official docs</a:t>
+            </a:r>
+          </a:p>
+          <a:p>
+            <a:r>
+              <a:rPr lang="en-US" dirty="0"/>
+              <a:t>If official docs are not “readable”, defer to official tutorials</a:t>
+            </a:r>
+          </a:p>
+          <a:p>
+            <a:r>
+              <a:rPr lang="en-US" dirty="0"/>
+              <a:t>Then online tutorials / guides</a:t>
+            </a:r>
+          </a:p>
+          <a:p>
+            <a:endParaRPr lang="en-US" dirty="0"/>
+          </a:p>
+        </p:txBody>
+      </p:sp>
+    </p:spTree>
+    <p:extLst>
+      <p:ext uri="{BB962C8B-B14F-4D97-AF65-F5344CB8AC3E}">
+        <p14:creationId xmlns:p14="http://schemas.microsoft.com/office/powerpoint/2010/main" val="3690170877"/>
+      </p:ext>
+    </p:extLst>
+  </p:cSld>
+  <p:clrMapOvr>
+    <a:masterClrMapping/>
+  </p:clrMapOvr>
+</p:sld>
+</file>
+
+<file path=ppt/slides/slide22.xml><?xml version="1.0" encoding="utf-8"?>
+<p:sld xmlns:a="http://schemas.openxmlformats.org/drawingml/2006/main" xmlns:r="http://schemas.openxmlformats.org/officeDocument/2006/relationships" xmlns:p="http://schemas.openxmlformats.org/presentationml/2006/main">
+  <p:cSld>
+    <p:spTree>
+      <p:nvGrpSpPr>
+        <p:cNvPr id="1" name=""/>
+        <p:cNvGrpSpPr/>
+        <p:nvPr/>
+      </p:nvGrpSpPr>
+      <p:grpSpPr>
+        <a:xfrm>
+          <a:off x="0" y="0"/>
+          <a:ext cx="0" cy="0"/>
+          <a:chOff x="0" y="0"/>
+          <a:chExt cx="0" cy="0"/>
+        </a:xfrm>
+      </p:grpSpPr>
+      <p:sp>
+        <p:nvSpPr>
+          <p:cNvPr id="2" name="Title 1">
+            <a:extLst>
+              <a:ext uri="{FF2B5EF4-FFF2-40B4-BE49-F238E27FC236}">
+                <a16:creationId xmlns:a16="http://schemas.microsoft.com/office/drawing/2014/main" id="{9DB4F2DF-A06A-E40D-DDFE-C600C320B31A}"/>
+              </a:ext>
+            </a:extLst>
+          </p:cNvPr>
+          <p:cNvSpPr>
+            <a:spLocks noGrp="1"/>
+          </p:cNvSpPr>
+          <p:nvPr>
+            <p:ph type="title"/>
+          </p:nvPr>
+        </p:nvSpPr>
+        <p:spPr/>
+        <p:txBody>
+          <a:bodyPr/>
+          <a:lstStyle/>
+          <a:p>
+            <a:r>
+              <a:rPr lang="en-US" dirty="0"/>
+              <a:t>Online Examples</a:t>
+            </a:r>
+          </a:p>
+        </p:txBody>
+      </p:sp>
+      <p:sp>
+        <p:nvSpPr>
+          <p:cNvPr id="3" name="Content Placeholder 2">
+            <a:extLst>
+              <a:ext uri="{FF2B5EF4-FFF2-40B4-BE49-F238E27FC236}">
+                <a16:creationId xmlns:a16="http://schemas.microsoft.com/office/drawing/2014/main" id="{65BEAC7A-C4A2-17E9-C2BA-92796270AF8E}"/>
+              </a:ext>
+            </a:extLst>
+          </p:cNvPr>
+          <p:cNvSpPr>
+            <a:spLocks noGrp="1"/>
+          </p:cNvSpPr>
+          <p:nvPr>
+            <p:ph idx="1"/>
+          </p:nvPr>
+        </p:nvSpPr>
+        <p:spPr/>
+        <p:txBody>
+          <a:bodyPr/>
+          <a:lstStyle/>
+          <a:p>
+            <a:r>
+              <a:rPr lang="en-US" dirty="0">
+                <a:hlinkClick r:id="rId2"/>
+              </a:rPr>
+              <a:t>Built-in Functions — Python 3.14.6 documentation</a:t>
+            </a:r>
+            <a:endParaRPr lang="en-US" dirty="0"/>
+          </a:p>
+          <a:p>
+            <a:r>
+              <a:rPr lang="en-US" dirty="0">
+                <a:hlinkClick r:id="rId3"/>
+              </a:rPr>
+              <a:t>Docker Docs</a:t>
+            </a:r>
+            <a:endParaRPr lang="en-US" dirty="0"/>
+          </a:p>
+          <a:p>
+            <a:r>
+              <a:rPr lang="en-US" dirty="0">
+                <a:hlinkClick r:id="rId4"/>
+              </a:rPr>
+              <a:t>Azure Command-Line Interface (CLI) documentation | Microsoft Learn</a:t>
+            </a:r>
+            <a:endParaRPr lang="en-US" dirty="0"/>
+          </a:p>
+          <a:p>
+            <a:endParaRPr lang="en-US" dirty="0"/>
+          </a:p>
+        </p:txBody>
+      </p:sp>
+    </p:spTree>
+    <p:extLst>
+      <p:ext uri="{BB962C8B-B14F-4D97-AF65-F5344CB8AC3E}">
+        <p14:creationId xmlns:p14="http://schemas.microsoft.com/office/powerpoint/2010/main" val="2011462998"/>
+      </p:ext>
+    </p:extLst>
+  </p:cSld>
+  <p:clrMapOvr>
+    <a:masterClrMapping/>
+  </p:clrMapOvr>
+</p:sld>
+</file>
+
+<file path=ppt/slides/slide23.xml><?xml version="1.0" encoding="utf-8"?>
+<p:sld xmlns:a="http://schemas.openxmlformats.org/drawingml/2006/main" xmlns:r="http://schemas.openxmlformats.org/officeDocument/2006/relationships" xmlns:p="http://schemas.openxmlformats.org/presentationml/2006/main">
+  <p:cSld>
+    <p:spTree>
+      <p:nvGrpSpPr>
+        <p:cNvPr id="1" name=""/>
+        <p:cNvGrpSpPr/>
+        <p:nvPr/>
+      </p:nvGrpSpPr>
+      <p:grpSpPr>
+        <a:xfrm>
+          <a:off x="0" y="0"/>
+          <a:ext cx="0" cy="0"/>
+          <a:chOff x="0" y="0"/>
+          <a:chExt cx="0" cy="0"/>
+        </a:xfrm>
+      </p:grpSpPr>
+      <p:sp>
+        <p:nvSpPr>
+          <p:cNvPr id="2" name="Title 1">
+            <a:extLst>
+              <a:ext uri="{FF2B5EF4-FFF2-40B4-BE49-F238E27FC236}">
+                <a16:creationId xmlns:a16="http://schemas.microsoft.com/office/drawing/2014/main" id="{5A1C6BDB-CF9A-E065-D1A3-B23B0459950A}"/>
+              </a:ext>
+            </a:extLst>
+          </p:cNvPr>
+          <p:cNvSpPr>
+            <a:spLocks noGrp="1"/>
+          </p:cNvSpPr>
+          <p:nvPr>
+            <p:ph type="title"/>
+          </p:nvPr>
+        </p:nvSpPr>
+        <p:spPr/>
+        <p:txBody>
+          <a:bodyPr/>
+          <a:lstStyle/>
+          <a:p>
+            <a:r>
+              <a:rPr lang="en-US" dirty="0"/>
+              <a:t>Truth in Lending</a:t>
+            </a:r>
+          </a:p>
+        </p:txBody>
+      </p:sp>
+      <p:sp>
+        <p:nvSpPr>
+          <p:cNvPr id="3" name="Content Placeholder 2">
+            <a:extLst>
+              <a:ext uri="{FF2B5EF4-FFF2-40B4-BE49-F238E27FC236}">
+                <a16:creationId xmlns:a16="http://schemas.microsoft.com/office/drawing/2014/main" id="{B860A6B0-A361-9806-D9C3-97112C9B80C7}"/>
+              </a:ext>
+            </a:extLst>
+          </p:cNvPr>
+          <p:cNvSpPr>
+            <a:spLocks noGrp="1"/>
+          </p:cNvSpPr>
+          <p:nvPr>
+            <p:ph idx="1"/>
+          </p:nvPr>
+        </p:nvSpPr>
+        <p:spPr/>
+        <p:txBody>
+          <a:bodyPr/>
+          <a:lstStyle/>
+          <a:p>
+            <a:r>
+              <a:rPr lang="en-US" dirty="0"/>
+              <a:t>All UI/UX come from software</a:t>
+            </a:r>
+          </a:p>
+          <a:p>
+            <a:r>
+              <a:rPr lang="en-US" dirty="0"/>
+              <a:t>Software is written by humans</a:t>
+            </a:r>
+          </a:p>
+          <a:p>
+            <a:r>
+              <a:rPr lang="en-US" dirty="0"/>
+              <a:t>Humans are… human</a:t>
+            </a:r>
+          </a:p>
+          <a:p>
+            <a:pPr lvl="1"/>
+            <a:r>
+              <a:rPr lang="en-US" dirty="0"/>
+              <a:t>Cannot anticipate all outcomes</a:t>
+            </a:r>
+          </a:p>
+          <a:p>
+            <a:pPr lvl="1"/>
+            <a:r>
+              <a:rPr lang="en-US" dirty="0"/>
+              <a:t>Cannot anticipate the myriad of ways users will mess it up</a:t>
+            </a:r>
+          </a:p>
+          <a:p>
+            <a:pPr lvl="1"/>
+            <a:r>
+              <a:rPr lang="en-US" dirty="0"/>
+              <a:t>Sometimes wrong! 🤷</a:t>
+            </a:r>
+          </a:p>
+          <a:p>
+            <a:endParaRPr lang="en-US" dirty="0"/>
+          </a:p>
+        </p:txBody>
+      </p:sp>
+    </p:spTree>
+    <p:extLst>
+      <p:ext uri="{BB962C8B-B14F-4D97-AF65-F5344CB8AC3E}">
+        <p14:creationId xmlns:p14="http://schemas.microsoft.com/office/powerpoint/2010/main" val="743346519"/>
+      </p:ext>
+    </p:extLst>
+  </p:cSld>
+  <p:clrMapOvr>
+    <a:masterClrMapping/>
+  </p:clrMapOvr>
+  <p:timing>
+    <p:tnLst>
+      <p:par>
+        <p:cTn id="1" dur="indefinite" restart="never" nodeType="tmRoot">
+          <p:childTnLst>
+            <p:seq concurrent="1" nextAc="seek">
+              <p:cTn id="2" dur="indefinite" nodeType="mainSeq">
+                <p:childTnLst>
+                  <p:par>
+                    <p:cTn id="3" fill="hold">
+                      <p:stCondLst>
+                        <p:cond delay="indefinite"/>
+                      </p:stCondLst>
+                      <p:childTnLst>
+                        <p:par>
+                          <p:cTn id="4" fill="hold">
+                            <p:stCondLst>
+                              <p:cond delay="0"/>
+                            </p:stCondLst>
+                            <p:childTnLst>
+                              <p:par>
+                                <p:cTn id="5" presetID="1" presetClass="entr" presetSubtype="0" fill="hold" grpId="0" nodeType="clickEffect">
+                                  <p:stCondLst>
+                                    <p:cond delay="0"/>
+                                  </p:stCondLst>
+                                  <p:childTnLst>
+                                    <p:set>
+                                      <p:cBhvr>
+                                        <p:cTn id="6" dur="1" fill="hold">
+                                          <p:stCondLst>
+                                            <p:cond delay="0"/>
+                                          </p:stCondLst>
+                                        </p:cTn>
+                                        <p:tgtEl>
+                                          <p:spTgt spid="3">
+                                            <p:txEl>
+                                              <p:pRg st="0" end="0"/>
+                                            </p:txEl>
+                                          </p:spTgt>
+                                        </p:tgtEl>
+                                        <p:attrNameLst>
+                                          <p:attrName>style.visibility</p:attrName>
+                                        </p:attrNameLst>
+                                      </p:cBhvr>
+                                      <p:to>
+                                        <p:strVal val="visible"/>
+                                      </p:to>
+                                    </p:set>
+                                  </p:childTnLst>
+                                </p:cTn>
+                              </p:par>
+                            </p:childTnLst>
+                          </p:cTn>
+                        </p:par>
+                      </p:childTnLst>
+                    </p:cTn>
+                  </p:par>
+                  <p:par>
+                    <p:cTn id="7" fill="hold">
+                      <p:stCondLst>
+                        <p:cond delay="indefinite"/>
+                      </p:stCondLst>
+                      <p:childTnLst>
+                        <p:par>
+                          <p:cTn id="8" fill="hold">
+                            <p:stCondLst>
+                              <p:cond delay="0"/>
+                            </p:stCondLst>
+                            <p:childTnLst>
+                              <p:par>
+                                <p:cTn id="9" presetID="1" presetClass="entr" presetSubtype="0" fill="hold" grpId="0" nodeType="clickEffect">
+                                  <p:stCondLst>
+                                    <p:cond delay="0"/>
+                                  </p:stCondLst>
+                                  <p:childTnLst>
+                                    <p:set>
+                                      <p:cBhvr>
+                                        <p:cTn id="10" dur="1" fill="hold">
+                                          <p:stCondLst>
+                                            <p:cond delay="0"/>
+                                          </p:stCondLst>
+                                        </p:cTn>
+                                        <p:tgtEl>
+                                          <p:spTgt spid="3">
+                                            <p:txEl>
+                                              <p:pRg st="1" end="1"/>
+                                            </p:txEl>
+                                          </p:spTgt>
+                                        </p:tgtEl>
+                                        <p:attrNameLst>
+                                          <p:attrName>style.visibility</p:attrName>
+                                        </p:attrNameLst>
+                                      </p:cBhvr>
+                                      <p:to>
+                                        <p:strVal val="visible"/>
+                                      </p:to>
+                                    </p:set>
+                                  </p:childTnLst>
+                                </p:cTn>
+                              </p:par>
+                            </p:childTnLst>
+                          </p:cTn>
+                        </p:par>
+                      </p:childTnLst>
+                    </p:cTn>
+                  </p:par>
+                  <p:par>
+                    <p:cTn id="11" fill="hold">
+                      <p:stCondLst>
+                        <p:cond delay="indefinite"/>
+                      </p:stCondLst>
+                      <p:childTnLst>
+                        <p:par>
+                          <p:cTn id="12" fill="hold">
+                            <p:stCondLst>
+                              <p:cond delay="0"/>
+                            </p:stCondLst>
+                            <p:childTnLst>
+                              <p:par>
+                                <p:cTn id="13" presetID="1" presetClass="entr" presetSubtype="0" fill="hold" grpId="0" nodeType="clickEffect">
+                                  <p:stCondLst>
+                                    <p:cond delay="0"/>
+                                  </p:stCondLst>
+                                  <p:childTnLst>
+                                    <p:set>
+                                      <p:cBhvr>
+                                        <p:cTn id="14" dur="1" fill="hold">
+                                          <p:stCondLst>
+                                            <p:cond delay="0"/>
+                                          </p:stCondLst>
+                                        </p:cTn>
+                                        <p:tgtEl>
+                                          <p:spTgt spid="3">
+                                            <p:txEl>
+                                              <p:pRg st="2" end="2"/>
+                                            </p:txEl>
+                                          </p:spTgt>
+                                        </p:tgtEl>
+                                        <p:attrNameLst>
+                                          <p:attrName>style.visibility</p:attrName>
+                                        </p:attrNameLst>
+                                      </p:cBhvr>
+                                      <p:to>
+                                        <p:strVal val="visible"/>
+                                      </p:to>
+                                    </p:set>
+                                  </p:childTnLst>
+                                </p:cTn>
+                              </p:par>
+                              <p:par>
+                                <p:cTn id="15" presetID="1" presetClass="entr" presetSubtype="0" fill="hold" grpId="0" nodeType="withEffect">
+                                  <p:stCondLst>
+                                    <p:cond delay="0"/>
+                                  </p:stCondLst>
+                                  <p:childTnLst>
+                                    <p:set>
+                                      <p:cBhvr>
+                                        <p:cTn id="16" dur="1" fill="hold">
+                                          <p:stCondLst>
+                                            <p:cond delay="0"/>
+                                          </p:stCondLst>
+                                        </p:cTn>
+                                        <p:tgtEl>
+                                          <p:spTgt spid="3">
+                                            <p:txEl>
+                                              <p:pRg st="3" end="3"/>
+                                            </p:txEl>
+                                          </p:spTgt>
+                                        </p:tgtEl>
+                                        <p:attrNameLst>
+                                          <p:attrName>style.visibility</p:attrName>
+                                        </p:attrNameLst>
+                                      </p:cBhvr>
+                                      <p:to>
+                                        <p:strVal val="visible"/>
+                                      </p:to>
+                                    </p:set>
+                                  </p:childTnLst>
+                                </p:cTn>
+                              </p:par>
+                              <p:par>
+                                <p:cTn id="17" presetID="1" presetClass="entr" presetSubtype="0" fill="hold" grpId="0" nodeType="withEffect">
+                                  <p:stCondLst>
+                                    <p:cond delay="0"/>
+                                  </p:stCondLst>
+                                  <p:childTnLst>
+                                    <p:set>
+                                      <p:cBhvr>
+                                        <p:cTn id="18" dur="1" fill="hold">
+                                          <p:stCondLst>
+                                            <p:cond delay="0"/>
+                                          </p:stCondLst>
+                                        </p:cTn>
+                                        <p:tgtEl>
+                                          <p:spTgt spid="3">
+                                            <p:txEl>
+                                              <p:pRg st="4" end="4"/>
+                                            </p:txEl>
+                                          </p:spTgt>
+                                        </p:tgtEl>
+                                        <p:attrNameLst>
+                                          <p:attrName>style.visibility</p:attrName>
+                                        </p:attrNameLst>
+                                      </p:cBhvr>
+                                      <p:to>
+                                        <p:strVal val="visible"/>
+                                      </p:to>
+                                    </p:set>
+                                  </p:childTnLst>
+                                </p:cTn>
+                              </p:par>
+                              <p:par>
+                                <p:cTn id="19" presetID="1" presetClass="entr" presetSubtype="0" fill="hold" grpId="0" nodeType="withEffect">
+                                  <p:stCondLst>
+                                    <p:cond delay="0"/>
+                                  </p:stCondLst>
+                                  <p:childTnLst>
+                                    <p:set>
+                                      <p:cBhvr>
+                                        <p:cTn id="20" dur="1" fill="hold">
+                                          <p:stCondLst>
+                                            <p:cond delay="0"/>
+                                          </p:stCondLst>
+                                        </p:cTn>
+                                        <p:tgtEl>
+                                          <p:spTgt spid="3">
+                                            <p:txEl>
+                                              <p:pRg st="5" end="5"/>
+                                            </p:txEl>
+                                          </p:spTgt>
+                                        </p:tgtEl>
+                                        <p:attrNameLst>
+                                          <p:attrName>style.visibility</p:attrName>
+                                        </p:attrNameLst>
+                                      </p:cBhvr>
+                                      <p:to>
+                                        <p:strVal val="visible"/>
+                                      </p:to>
+                                    </p:set>
+                                  </p:childTnLst>
+                                </p:cTn>
+                              </p:par>
+                            </p:childTnLst>
+                          </p:cTn>
+                        </p:par>
+                      </p:childTnLst>
+                    </p:cTn>
+                  </p:par>
+                </p:childTnLst>
+              </p:cTn>
+              <p:prevCondLst>
+                <p:cond evt="onPrev" delay="0">
+                  <p:tgtEl>
+                    <p:sldTgt/>
+                  </p:tgtEl>
+                </p:cond>
+              </p:prevCondLst>
+              <p:nextCondLst>
+                <p:cond evt="onNext" delay="0">
+                  <p:tgtEl>
+                    <p:sldTgt/>
+                  </p:tgtEl>
+                </p:cond>
+              </p:nextCondLst>
+            </p:seq>
+          </p:childTnLst>
+        </p:cTn>
+      </p:par>
+    </p:tnLst>
+    <p:bldLst>
+      <p:bldP spid="3" grpId="0" build="p"/>
+    </p:bldLst>
+  </p:timing>
+</p:sld>
+</file>
+
+<file path=ppt/slides/slide24.xml><?xml version="1.0" encoding="utf-8"?>
+<p:sld xmlns:a="http://schemas.openxmlformats.org/drawingml/2006/main" xmlns:r="http://schemas.openxmlformats.org/officeDocument/2006/relationships" xmlns:p="http://schemas.openxmlformats.org/presentationml/2006/main">
+  <p:cSld>
+    <p:spTree>
+      <p:nvGrpSpPr>
+        <p:cNvPr id="1" name=""/>
+        <p:cNvGrpSpPr/>
+        <p:nvPr/>
+      </p:nvGrpSpPr>
+      <p:grpSpPr>
+        <a:xfrm>
+          <a:off x="0" y="0"/>
+          <a:ext cx="0" cy="0"/>
+          <a:chOff x="0" y="0"/>
+          <a:chExt cx="0" cy="0"/>
+        </a:xfrm>
+      </p:grpSpPr>
+      <p:sp>
+        <p:nvSpPr>
+          <p:cNvPr id="2" name="Title 1">
+            <a:extLst>
+              <a:ext uri="{FF2B5EF4-FFF2-40B4-BE49-F238E27FC236}">
+                <a16:creationId xmlns:a16="http://schemas.microsoft.com/office/drawing/2014/main" id="{8D3BCC3E-3DC9-E773-3FF1-CDF396B7E726}"/>
+              </a:ext>
+            </a:extLst>
+          </p:cNvPr>
+          <p:cNvSpPr>
+            <a:spLocks noGrp="1"/>
+          </p:cNvSpPr>
+          <p:nvPr>
+            <p:ph type="title"/>
+          </p:nvPr>
+        </p:nvSpPr>
+        <p:spPr/>
+        <p:txBody>
+          <a:bodyPr/>
+          <a:lstStyle/>
+          <a:p>
+            <a:r>
+              <a:rPr lang="en-US" dirty="0"/>
+              <a:t>Following Documentation</a:t>
+            </a:r>
+          </a:p>
+        </p:txBody>
+      </p:sp>
+      <p:sp>
+        <p:nvSpPr>
+          <p:cNvPr id="3" name="Content Placeholder 2">
+            <a:extLst>
+              <a:ext uri="{FF2B5EF4-FFF2-40B4-BE49-F238E27FC236}">
+                <a16:creationId xmlns:a16="http://schemas.microsoft.com/office/drawing/2014/main" id="{2B964104-7D38-7412-6BCE-1796D82C1FA5}"/>
+              </a:ext>
+            </a:extLst>
+          </p:cNvPr>
+          <p:cNvSpPr>
+            <a:spLocks noGrp="1"/>
+          </p:cNvSpPr>
+          <p:nvPr>
+            <p:ph idx="1"/>
+          </p:nvPr>
+        </p:nvSpPr>
+        <p:spPr/>
+        <p:txBody>
+          <a:bodyPr/>
+          <a:lstStyle/>
+          <a:p>
+            <a:r>
+              <a:rPr lang="en-US" dirty="0"/>
+              <a:t>Precision matters</a:t>
+            </a:r>
+          </a:p>
+          <a:p>
+            <a:r>
+              <a:rPr lang="en-US" dirty="0"/>
+              <a:t>Order matters</a:t>
+            </a:r>
+          </a:p>
+          <a:p>
+            <a:r>
+              <a:rPr lang="en-US" dirty="0"/>
+              <a:t>Slow is smooth…</a:t>
+            </a:r>
+          </a:p>
+          <a:p>
+            <a:r>
+              <a:rPr lang="en-US" dirty="0"/>
+              <a:t>Validate where possible</a:t>
+            </a:r>
+          </a:p>
+          <a:p>
+            <a:endParaRPr lang="en-US" dirty="0"/>
+          </a:p>
+        </p:txBody>
+      </p:sp>
+    </p:spTree>
+    <p:extLst>
+      <p:ext uri="{BB962C8B-B14F-4D97-AF65-F5344CB8AC3E}">
+        <p14:creationId xmlns:p14="http://schemas.microsoft.com/office/powerpoint/2010/main" val="3513312863"/>
       </p:ext>
     </p:extLst>
   </p:cSld>

</xml_diff>